<commit_message>
Fix: deck actually rebuilt with 48 percent on cover and status tile
Co-Authored-By: Claude Fable 5 <noreply@anthropic.com>
</commit_message>
<xml_diff>
--- a/docs/presentations/Group9_Presentation4_Week4.pptx
+++ b/docs/presentations/Group9_Presentation4_Week4.pptx
@@ -4379,7 +4379,7 @@
                 <a:ea typeface="Arial" pitchFamily="34" charset="-122"/>
                 <a:cs typeface="Arial" pitchFamily="34" charset="-120"/>
               </a:rPr>
-              <a:t>42% vs 25% target, ahead</a:t>
+              <a:t>48% vs 25% target, ahead</a:t>
             </a:r>
             <a:endParaRPr lang="en-US" sz="1050" dirty="0"/>
           </a:p>
@@ -4878,7 +4878,7 @@
                 <a:ea typeface="Arial" pitchFamily="34" charset="-122"/>
                 <a:cs typeface="Arial" pitchFamily="34" charset="-120"/>
               </a:rPr>
-              <a:t>42%</a:t>
+              <a:t>48%</a:t>
             </a:r>
             <a:endParaRPr lang="en-US" sz="2700" dirty="0"/>
           </a:p>

</xml_diff>